<commit_message>
Update RTA role on portfolio page 3 and record it in CV source of truth
Co-Authored-By: Claude Opus 5.5 <noreply@anthropic.com>
Claude-Session: https://claude.ai/code/session_01YKzu5MUCab6rqLw14CUW7v
</commit_message>
<xml_diff>
--- a/01-relocation/response-able-futures/Sara-Radwan-portfolio-6-pages.pptx
+++ b/01-relocation/response-able-futures/Sara-Radwan-portfolio-6-pages.pptx
@@ -3225,21 +3225,7 @@
                 <a:ea typeface="Arial" pitchFamily="34" charset="-122"/>
                 <a:cs typeface="Arial" pitchFamily="34" charset="-120"/>
               </a:rPr>
-              <a:t>My role: co-founder and creative lead of the studio that delivered it. Concept, identity, on-site direction on both days. </a:t>
-            </a:r>
-            <a:pPr indent="0" marL="0">
-              <a:buNone/>
-            </a:pPr>
-            <a:r>
-              <a:rPr lang="en-US" sz="1200" i="1" dirty="0">
-                <a:solidFill>
-                  <a:srgbClr val="B4532A"/>
-                </a:solidFill>
-                <a:latin typeface="Arial" pitchFamily="34" charset="0"/>
-                <a:ea typeface="Arial" pitchFamily="34" charset="-122"/>
-                <a:cs typeface="Arial" pitchFamily="34" charset="-120"/>
-              </a:rPr>
-              <a:t>[What you designed yourself.]</a:t>
+              <a:t>My role: creative lead, at the studio I co-founded. I conceived all six interactive activations and led the creative direction of the whole experience, from concept and visual identity to on-site execution.</a:t>
             </a:r>
             <a:endParaRPr lang="en-US" sz="1200" dirty="0"/>
           </a:p>

</xml_diff>